<commit_message>
Brand executive decks for MyTicketSeller, Komfort Place Signature, NaijaFoodFestival, CONVVA and Verdaso
Each deck now uses its own palette, logo and title layout instead of the shared navy template.
</commit_message>
<xml_diff>
--- a/01-delivered-case-studies/komfort-place-signature-digital-growth/Deck/Executive_Deck.pptx
+++ b/01-delivered-case-studies/komfort-place-signature-digital-growth/Deck/Executive_Deck.pptx
@@ -1391,7 +1391,7 @@
     <p:bg>
       <p:bgPr>
         <a:solidFill>
-          <a:srgbClr val="15253D"/>
+          <a:srgbClr val="FFFFFF"/>
         </a:solidFill>
       </p:bgPr>
     </p:bg>
@@ -1436,7 +1436,7 @@
             <a:r>
               <a:rPr lang="en-US" sz="1300" b="1" spc="200" kern="0" dirty="0">
                 <a:solidFill>
-                  <a:srgbClr val="5EEAD4"/>
+                  <a:srgbClr val="8E24D9"/>
                 </a:solidFill>
                 <a:latin typeface="Arial" pitchFamily="34" charset="0"/>
                 <a:ea typeface="Arial" pitchFamily="34" charset="-122"/>
@@ -1457,7 +1457,7 @@
         <p:spPr>
           <a:xfrm>
             <a:off x="731520" y="1645920"/>
-            <a:ext cx="10515600" cy="1463040"/>
+            <a:ext cx="7620000" cy="1463040"/>
           </a:xfrm>
           <a:prstGeom prst="rect">
             <a:avLst/>
@@ -1475,11 +1475,11 @@
             <a:r>
               <a:rPr lang="en-US" sz="4000" b="1" dirty="0">
                 <a:solidFill>
-                  <a:srgbClr val="FFFFFF"/>
+                  <a:srgbClr val="2B1638"/>
                 </a:solidFill>
-                <a:latin typeface="Arial" pitchFamily="34" charset="0"/>
-                <a:ea typeface="Arial" pitchFamily="34" charset="-122"/>
-                <a:cs typeface="Arial" pitchFamily="34" charset="-120"/>
+                <a:latin typeface="Liberation Serif" pitchFamily="34" charset="0"/>
+                <a:ea typeface="Liberation Serif" pitchFamily="34" charset="-122"/>
+                <a:cs typeface="Liberation Serif" pitchFamily="34" charset="-120"/>
               </a:rPr>
               <a:t>Komfort Place Signature Digital Growth</a:t>
             </a:r>
@@ -1514,7 +1514,7 @@
             <a:r>
               <a:rPr lang="en-US" sz="1800" dirty="0">
                 <a:solidFill>
-                  <a:srgbClr val="CBD5E1"/>
+                  <a:srgbClr val="4B5563"/>
                 </a:solidFill>
                 <a:latin typeface="Arial" pitchFamily="34" charset="0"/>
                 <a:ea typeface="Arial" pitchFamily="34" charset="-122"/>
@@ -1543,11 +1543,15 @@
           <a:noFill/>
           <a:ln w="25400">
             <a:solidFill>
-              <a:srgbClr val="5EEAD4"/>
+              <a:srgbClr val="8E24D9"/>
             </a:solidFill>
             <a:prstDash val="solid"/>
           </a:ln>
         </p:spPr>
+        <p:txBody>
+          <a:bodyPr/>
+          <a:p/>
+        </p:txBody>
       </p:sp>
       <p:sp>
         <p:nvSpPr>
@@ -1579,7 +1583,7 @@
             <a:r>
               <a:rPr lang="en-US" sz="1400" b="1" dirty="0">
                 <a:solidFill>
-                  <a:srgbClr val="E2E8F0"/>
+                  <a:srgbClr val="1F2937"/>
                 </a:solidFill>
                 <a:latin typeface="Arial" pitchFamily="34" charset="0"/>
                 <a:ea typeface="Arial" pitchFamily="34" charset="-122"/>
@@ -1590,7 +1594,7 @@
             <a:r>
               <a:rPr lang="en-US" sz="1400" b="0" dirty="0">
                 <a:solidFill>
-                  <a:srgbClr val="E2E8F0"/>
+                  <a:srgbClr val="1F2937"/>
                 </a:solidFill>
                 <a:latin typeface="Arial" pitchFamily="34" charset="0"/>
                 <a:ea typeface="Arial" pitchFamily="34" charset="-122"/>
@@ -1616,7 +1620,7 @@
             <a:r>
               <a:rPr lang="en-US" sz="1400" b="1" dirty="0">
                 <a:solidFill>
-                  <a:srgbClr val="E2E8F0"/>
+                  <a:srgbClr val="1F2937"/>
                 </a:solidFill>
                 <a:latin typeface="Arial" pitchFamily="34" charset="0"/>
                 <a:ea typeface="Arial" pitchFamily="34" charset="-122"/>
@@ -1627,7 +1631,7 @@
             <a:r>
               <a:rPr lang="en-US" sz="1400" b="0" dirty="0">
                 <a:solidFill>
-                  <a:srgbClr val="E2E8F0"/>
+                  <a:srgbClr val="1F2937"/>
                 </a:solidFill>
                 <a:latin typeface="Arial" pitchFamily="34" charset="0"/>
                 <a:ea typeface="Arial" pitchFamily="34" charset="-122"/>
@@ -1653,7 +1657,7 @@
             <a:r>
               <a:rPr lang="en-US" sz="1400" b="1" dirty="0">
                 <a:solidFill>
-                  <a:srgbClr val="E2E8F0"/>
+                  <a:srgbClr val="1F2937"/>
                 </a:solidFill>
                 <a:latin typeface="Arial" pitchFamily="34" charset="0"/>
                 <a:ea typeface="Arial" pitchFamily="34" charset="-122"/>
@@ -1664,7 +1668,7 @@
             <a:r>
               <a:rPr lang="en-US" sz="1400" b="0" dirty="0">
                 <a:solidFill>
-                  <a:srgbClr val="E2E8F0"/>
+                  <a:srgbClr val="1F2937"/>
                 </a:solidFill>
                 <a:latin typeface="Arial" pitchFamily="34" charset="0"/>
                 <a:ea typeface="Arial" pitchFamily="34" charset="-122"/>
@@ -1682,6 +1686,118 @@
           </a:p>
         </p:txBody>
       </p:sp>
+      <p:sp>
+        <p:nvSpPr>
+          <p:cNvPr id="7" name="Rectangle 6"/>
+          <p:cNvSpPr/>
+          <p:nvPr/>
+        </p:nvSpPr>
+        <p:spPr>
+          <a:xfrm>
+            <a:off x="0" y="0"/>
+            <a:ext cx="320040" cy="6858000"/>
+          </a:xfrm>
+          <a:prstGeom prst="rect">
+            <a:avLst/>
+          </a:prstGeom>
+          <a:solidFill>
+            <a:srgbClr val="2B1638"/>
+          </a:solidFill>
+          <a:ln>
+            <a:noFill/>
+          </a:ln>
+          <a:effectLst/>
+        </p:spPr>
+        <p:style>
+          <a:lnRef idx="1">
+            <a:schemeClr val="accent1"/>
+          </a:lnRef>
+          <a:fillRef idx="3">
+            <a:schemeClr val="accent1"/>
+          </a:fillRef>
+          <a:effectRef idx="2">
+            <a:schemeClr val="accent1"/>
+          </a:effectRef>
+          <a:fontRef idx="minor">
+            <a:schemeClr val="lt1"/>
+          </a:fontRef>
+        </p:style>
+        <p:txBody>
+          <a:bodyPr rtlCol="0" anchor="ctr"/>
+          <a:lstStyle/>
+          <a:p>
+            <a:pPr algn="ctr"/>
+          </a:p>
+        </p:txBody>
+      </p:sp>
+      <p:sp>
+        <p:nvSpPr>
+          <p:cNvPr id="8" name="Rectangle 7"/>
+          <p:cNvSpPr/>
+          <p:nvPr/>
+        </p:nvSpPr>
+        <p:spPr>
+          <a:xfrm>
+            <a:off x="320040" y="0"/>
+            <a:ext cx="73152" cy="6858000"/>
+          </a:xfrm>
+          <a:prstGeom prst="rect">
+            <a:avLst/>
+          </a:prstGeom>
+          <a:solidFill>
+            <a:srgbClr val="F4B6C6"/>
+          </a:solidFill>
+          <a:ln>
+            <a:noFill/>
+          </a:ln>
+          <a:effectLst/>
+        </p:spPr>
+        <p:style>
+          <a:lnRef idx="1">
+            <a:schemeClr val="accent1"/>
+          </a:lnRef>
+          <a:fillRef idx="3">
+            <a:schemeClr val="accent1"/>
+          </a:fillRef>
+          <a:effectRef idx="2">
+            <a:schemeClr val="accent1"/>
+          </a:effectRef>
+          <a:fontRef idx="minor">
+            <a:schemeClr val="lt1"/>
+          </a:fontRef>
+        </p:style>
+        <p:txBody>
+          <a:bodyPr rtlCol="0" anchor="ctr"/>
+          <a:lstStyle/>
+          <a:p>
+            <a:pPr algn="ctr"/>
+          </a:p>
+        </p:txBody>
+      </p:sp>
+      <p:pic>
+        <p:nvPicPr>
+          <p:cNvPr id="9" name="Picture 8" descr="kom_logo.png"/>
+          <p:cNvPicPr>
+            <a:picLocks noChangeAspect="1"/>
+          </p:cNvPicPr>
+          <p:nvPr/>
+        </p:nvPicPr>
+        <p:blipFill>
+          <a:blip r:embed="rId3"/>
+          <a:stretch>
+            <a:fillRect/>
+          </a:stretch>
+        </p:blipFill>
+        <p:spPr>
+          <a:xfrm>
+            <a:off x="8442960" y="458724"/>
+            <a:ext cx="3108960" cy="1917192"/>
+          </a:xfrm>
+          <a:prstGeom prst="rect">
+            <a:avLst/>
+          </a:prstGeom>
+        </p:spPr>
+      </p:pic>
     </p:spTree>
   </p:cSld>
   <p:clrMapOvr>
@@ -1741,11 +1857,11 @@
             <a:r>
               <a:rPr lang="en-US" sz="2600" b="1" dirty="0">
                 <a:solidFill>
-                  <a:srgbClr val="15253D"/>
+                  <a:srgbClr val="2B1638"/>
                 </a:solidFill>
-                <a:latin typeface="Arial" pitchFamily="34" charset="0"/>
-                <a:ea typeface="Arial" pitchFamily="34" charset="-122"/>
-                <a:cs typeface="Arial" pitchFamily="34" charset="-120"/>
+                <a:latin typeface="Liberation Serif" pitchFamily="34" charset="0"/>
+                <a:ea typeface="Liberation Serif" pitchFamily="34" charset="-122"/>
+                <a:cs typeface="Liberation Serif" pitchFamily="34" charset="-120"/>
               </a:rPr>
               <a:t>The problem and what discovery found</a:t>
             </a:r>
@@ -1768,11 +1884,11 @@
             <a:avLst/>
           </a:prstGeom>
           <a:solidFill>
-            <a:srgbClr val="F4F7FB"/>
+            <a:srgbClr val="FBF5FB"/>
           </a:solidFill>
           <a:ln w="12700">
             <a:solidFill>
-              <a:srgbClr val="F4F7FB"/>
+              <a:srgbClr val="FBF5FB"/>
             </a:solidFill>
             <a:prstDash val="solid"/>
           </a:ln>
@@ -1809,7 +1925,7 @@
             <a:r>
               <a:rPr lang="en-US" sz="1400" b="1" dirty="0">
                 <a:solidFill>
-                  <a:srgbClr val="0F766E"/>
+                  <a:srgbClr val="8E24D9"/>
                 </a:solidFill>
                 <a:latin typeface="Arial" pitchFamily="34" charset="0"/>
                 <a:ea typeface="Arial" pitchFamily="34" charset="-122"/>
@@ -1887,7 +2003,7 @@
             <a:r>
               <a:rPr lang="en-US" sz="1400" b="1" dirty="0">
                 <a:solidFill>
-                  <a:srgbClr val="0F766E"/>
+                  <a:srgbClr val="8E24D9"/>
                 </a:solidFill>
                 <a:latin typeface="Arial" pitchFamily="34" charset="0"/>
                 <a:ea typeface="Arial" pitchFamily="34" charset="-122"/>
@@ -1914,11 +2030,11 @@
             <a:avLst/>
           </a:prstGeom>
           <a:solidFill>
-            <a:srgbClr val="EA580C"/>
+            <a:srgbClr val="A020F0"/>
           </a:solidFill>
           <a:ln w="12700">
             <a:solidFill>
-              <a:srgbClr val="EA580C"/>
+              <a:srgbClr val="A020F0"/>
             </a:solidFill>
             <a:prstDash val="solid"/>
           </a:ln>
@@ -2021,11 +2137,11 @@
             <a:avLst/>
           </a:prstGeom>
           <a:solidFill>
-            <a:srgbClr val="EA580C"/>
+            <a:srgbClr val="A020F0"/>
           </a:solidFill>
           <a:ln w="12700">
             <a:solidFill>
-              <a:srgbClr val="EA580C"/>
+              <a:srgbClr val="A020F0"/>
             </a:solidFill>
             <a:prstDash val="solid"/>
           </a:ln>
@@ -2128,11 +2244,11 @@
             <a:avLst/>
           </a:prstGeom>
           <a:solidFill>
-            <a:srgbClr val="EA580C"/>
+            <a:srgbClr val="A020F0"/>
           </a:solidFill>
           <a:ln w="12700">
             <a:solidFill>
-              <a:srgbClr val="EA580C"/>
+              <a:srgbClr val="A020F0"/>
             </a:solidFill>
             <a:prstDash val="solid"/>
           </a:ln>
@@ -2298,6 +2414,118 @@
           </a:p>
         </p:txBody>
       </p:sp>
+      <p:sp>
+        <p:nvSpPr>
+          <p:cNvPr id="18" name="Rectangle 17"/>
+          <p:cNvSpPr/>
+          <p:nvPr/>
+        </p:nvSpPr>
+        <p:spPr>
+          <a:xfrm>
+            <a:off x="0" y="0"/>
+            <a:ext cx="12192000" cy="82296"/>
+          </a:xfrm>
+          <a:prstGeom prst="rect">
+            <a:avLst/>
+          </a:prstGeom>
+          <a:solidFill>
+            <a:srgbClr val="2B1638"/>
+          </a:solidFill>
+          <a:ln>
+            <a:noFill/>
+          </a:ln>
+          <a:effectLst/>
+        </p:spPr>
+        <p:style>
+          <a:lnRef idx="1">
+            <a:schemeClr val="accent1"/>
+          </a:lnRef>
+          <a:fillRef idx="3">
+            <a:schemeClr val="accent1"/>
+          </a:fillRef>
+          <a:effectRef idx="2">
+            <a:schemeClr val="accent1"/>
+          </a:effectRef>
+          <a:fontRef idx="minor">
+            <a:schemeClr val="lt1"/>
+          </a:fontRef>
+        </p:style>
+        <p:txBody>
+          <a:bodyPr rtlCol="0" anchor="ctr"/>
+          <a:lstStyle/>
+          <a:p>
+            <a:pPr algn="ctr"/>
+          </a:p>
+        </p:txBody>
+      </p:sp>
+      <p:sp>
+        <p:nvSpPr>
+          <p:cNvPr id="19" name="Rectangle 18"/>
+          <p:cNvSpPr/>
+          <p:nvPr/>
+        </p:nvSpPr>
+        <p:spPr>
+          <a:xfrm>
+            <a:off x="0" y="82296"/>
+            <a:ext cx="1463040" cy="45720"/>
+          </a:xfrm>
+          <a:prstGeom prst="rect">
+            <a:avLst/>
+          </a:prstGeom>
+          <a:solidFill>
+            <a:srgbClr val="A020F0"/>
+          </a:solidFill>
+          <a:ln>
+            <a:noFill/>
+          </a:ln>
+          <a:effectLst/>
+        </p:spPr>
+        <p:style>
+          <a:lnRef idx="1">
+            <a:schemeClr val="accent1"/>
+          </a:lnRef>
+          <a:fillRef idx="3">
+            <a:schemeClr val="accent1"/>
+          </a:fillRef>
+          <a:effectRef idx="2">
+            <a:schemeClr val="accent1"/>
+          </a:effectRef>
+          <a:fontRef idx="minor">
+            <a:schemeClr val="lt1"/>
+          </a:fontRef>
+        </p:style>
+        <p:txBody>
+          <a:bodyPr rtlCol="0" anchor="ctr"/>
+          <a:lstStyle/>
+          <a:p>
+            <a:pPr algn="ctr"/>
+          </a:p>
+        </p:txBody>
+      </p:sp>
+      <p:pic>
+        <p:nvPicPr>
+          <p:cNvPr id="20" name="Picture 19" descr="kom_logo.png"/>
+          <p:cNvPicPr>
+            <a:picLocks noChangeAspect="1"/>
+          </p:cNvPicPr>
+          <p:nvPr/>
+        </p:nvPicPr>
+        <p:blipFill>
+          <a:blip r:embed="rId3"/>
+          <a:stretch>
+            <a:fillRect/>
+          </a:stretch>
+        </p:blipFill>
+        <p:spPr>
+          <a:xfrm>
+            <a:off x="10554730" y="6336792"/>
+            <a:ext cx="622780" cy="384048"/>
+          </a:xfrm>
+          <a:prstGeom prst="rect">
+            <a:avLst/>
+          </a:prstGeom>
+        </p:spPr>
+      </p:pic>
     </p:spTree>
   </p:cSld>
   <p:clrMapOvr>
@@ -2357,11 +2585,11 @@
             <a:r>
               <a:rPr lang="en-US" sz="2600" b="1" dirty="0">
                 <a:solidFill>
-                  <a:srgbClr val="15253D"/>
+                  <a:srgbClr val="2B1638"/>
                 </a:solidFill>
-                <a:latin typeface="Arial" pitchFamily="34" charset="0"/>
-                <a:ea typeface="Arial" pitchFamily="34" charset="-122"/>
-                <a:cs typeface="Arial" pitchFamily="34" charset="-120"/>
+                <a:latin typeface="Liberation Serif" pitchFamily="34" charset="0"/>
+                <a:ea typeface="Liberation Serif" pitchFamily="34" charset="-122"/>
+                <a:cs typeface="Liberation Serif" pitchFamily="34" charset="-120"/>
               </a:rPr>
               <a:t>As-Is process</a:t>
             </a:r>
@@ -2504,6 +2732,118 @@
           <a:xfrm>
             <a:off x="457200" y="1280160"/>
             <a:ext cx="11247120" cy="3578629"/>
+          </a:xfrm>
+          <a:prstGeom prst="rect">
+            <a:avLst/>
+          </a:prstGeom>
+        </p:spPr>
+      </p:pic>
+      <p:sp>
+        <p:nvSpPr>
+          <p:cNvPr id="8" name="Rectangle 7"/>
+          <p:cNvSpPr/>
+          <p:nvPr/>
+        </p:nvSpPr>
+        <p:spPr>
+          <a:xfrm>
+            <a:off x="0" y="0"/>
+            <a:ext cx="12192000" cy="82296"/>
+          </a:xfrm>
+          <a:prstGeom prst="rect">
+            <a:avLst/>
+          </a:prstGeom>
+          <a:solidFill>
+            <a:srgbClr val="2B1638"/>
+          </a:solidFill>
+          <a:ln>
+            <a:noFill/>
+          </a:ln>
+          <a:effectLst/>
+        </p:spPr>
+        <p:style>
+          <a:lnRef idx="1">
+            <a:schemeClr val="accent1"/>
+          </a:lnRef>
+          <a:fillRef idx="3">
+            <a:schemeClr val="accent1"/>
+          </a:fillRef>
+          <a:effectRef idx="2">
+            <a:schemeClr val="accent1"/>
+          </a:effectRef>
+          <a:fontRef idx="minor">
+            <a:schemeClr val="lt1"/>
+          </a:fontRef>
+        </p:style>
+        <p:txBody>
+          <a:bodyPr rtlCol="0" anchor="ctr"/>
+          <a:lstStyle/>
+          <a:p>
+            <a:pPr algn="ctr"/>
+          </a:p>
+        </p:txBody>
+      </p:sp>
+      <p:sp>
+        <p:nvSpPr>
+          <p:cNvPr id="9" name="Rectangle 8"/>
+          <p:cNvSpPr/>
+          <p:nvPr/>
+        </p:nvSpPr>
+        <p:spPr>
+          <a:xfrm>
+            <a:off x="0" y="82296"/>
+            <a:ext cx="1463040" cy="45720"/>
+          </a:xfrm>
+          <a:prstGeom prst="rect">
+            <a:avLst/>
+          </a:prstGeom>
+          <a:solidFill>
+            <a:srgbClr val="A020F0"/>
+          </a:solidFill>
+          <a:ln>
+            <a:noFill/>
+          </a:ln>
+          <a:effectLst/>
+        </p:spPr>
+        <p:style>
+          <a:lnRef idx="1">
+            <a:schemeClr val="accent1"/>
+          </a:lnRef>
+          <a:fillRef idx="3">
+            <a:schemeClr val="accent1"/>
+          </a:fillRef>
+          <a:effectRef idx="2">
+            <a:schemeClr val="accent1"/>
+          </a:effectRef>
+          <a:fontRef idx="minor">
+            <a:schemeClr val="lt1"/>
+          </a:fontRef>
+        </p:style>
+        <p:txBody>
+          <a:bodyPr rtlCol="0" anchor="ctr"/>
+          <a:lstStyle/>
+          <a:p>
+            <a:pPr algn="ctr"/>
+          </a:p>
+        </p:txBody>
+      </p:sp>
+      <p:pic>
+        <p:nvPicPr>
+          <p:cNvPr id="10" name="Picture 9" descr="kom_logo.png"/>
+          <p:cNvPicPr>
+            <a:picLocks noChangeAspect="1"/>
+          </p:cNvPicPr>
+          <p:nvPr/>
+        </p:nvPicPr>
+        <p:blipFill>
+          <a:blip r:embed="rId5"/>
+          <a:stretch>
+            <a:fillRect/>
+          </a:stretch>
+        </p:blipFill>
+        <p:spPr>
+          <a:xfrm>
+            <a:off x="10554730" y="6336792"/>
+            <a:ext cx="622780" cy="384048"/>
           </a:xfrm>
           <a:prstGeom prst="rect">
             <a:avLst/>
@@ -2569,11 +2909,11 @@
             <a:r>
               <a:rPr lang="en-US" sz="2600" b="1" dirty="0">
                 <a:solidFill>
-                  <a:srgbClr val="15253D"/>
+                  <a:srgbClr val="2B1638"/>
                 </a:solidFill>
-                <a:latin typeface="Arial" pitchFamily="34" charset="0"/>
-                <a:ea typeface="Arial" pitchFamily="34" charset="-122"/>
-                <a:cs typeface="Arial" pitchFamily="34" charset="-120"/>
+                <a:latin typeface="Liberation Serif" pitchFamily="34" charset="0"/>
+                <a:ea typeface="Liberation Serif" pitchFamily="34" charset="-122"/>
+                <a:cs typeface="Liberation Serif" pitchFamily="34" charset="-120"/>
               </a:rPr>
               <a:t>To-Be process</a:t>
             </a:r>
@@ -2716,6 +3056,118 @@
           <a:xfrm>
             <a:off x="457200" y="1280160"/>
             <a:ext cx="11247120" cy="3578629"/>
+          </a:xfrm>
+          <a:prstGeom prst="rect">
+            <a:avLst/>
+          </a:prstGeom>
+        </p:spPr>
+      </p:pic>
+      <p:sp>
+        <p:nvSpPr>
+          <p:cNvPr id="8" name="Rectangle 7"/>
+          <p:cNvSpPr/>
+          <p:nvPr/>
+        </p:nvSpPr>
+        <p:spPr>
+          <a:xfrm>
+            <a:off x="0" y="0"/>
+            <a:ext cx="12192000" cy="82296"/>
+          </a:xfrm>
+          <a:prstGeom prst="rect">
+            <a:avLst/>
+          </a:prstGeom>
+          <a:solidFill>
+            <a:srgbClr val="2B1638"/>
+          </a:solidFill>
+          <a:ln>
+            <a:noFill/>
+          </a:ln>
+          <a:effectLst/>
+        </p:spPr>
+        <p:style>
+          <a:lnRef idx="1">
+            <a:schemeClr val="accent1"/>
+          </a:lnRef>
+          <a:fillRef idx="3">
+            <a:schemeClr val="accent1"/>
+          </a:fillRef>
+          <a:effectRef idx="2">
+            <a:schemeClr val="accent1"/>
+          </a:effectRef>
+          <a:fontRef idx="minor">
+            <a:schemeClr val="lt1"/>
+          </a:fontRef>
+        </p:style>
+        <p:txBody>
+          <a:bodyPr rtlCol="0" anchor="ctr"/>
+          <a:lstStyle/>
+          <a:p>
+            <a:pPr algn="ctr"/>
+          </a:p>
+        </p:txBody>
+      </p:sp>
+      <p:sp>
+        <p:nvSpPr>
+          <p:cNvPr id="9" name="Rectangle 8"/>
+          <p:cNvSpPr/>
+          <p:nvPr/>
+        </p:nvSpPr>
+        <p:spPr>
+          <a:xfrm>
+            <a:off x="0" y="82296"/>
+            <a:ext cx="1463040" cy="45720"/>
+          </a:xfrm>
+          <a:prstGeom prst="rect">
+            <a:avLst/>
+          </a:prstGeom>
+          <a:solidFill>
+            <a:srgbClr val="A020F0"/>
+          </a:solidFill>
+          <a:ln>
+            <a:noFill/>
+          </a:ln>
+          <a:effectLst/>
+        </p:spPr>
+        <p:style>
+          <a:lnRef idx="1">
+            <a:schemeClr val="accent1"/>
+          </a:lnRef>
+          <a:fillRef idx="3">
+            <a:schemeClr val="accent1"/>
+          </a:fillRef>
+          <a:effectRef idx="2">
+            <a:schemeClr val="accent1"/>
+          </a:effectRef>
+          <a:fontRef idx="minor">
+            <a:schemeClr val="lt1"/>
+          </a:fontRef>
+        </p:style>
+        <p:txBody>
+          <a:bodyPr rtlCol="0" anchor="ctr"/>
+          <a:lstStyle/>
+          <a:p>
+            <a:pPr algn="ctr"/>
+          </a:p>
+        </p:txBody>
+      </p:sp>
+      <p:pic>
+        <p:nvPicPr>
+          <p:cNvPr id="10" name="Picture 9" descr="kom_logo.png"/>
+          <p:cNvPicPr>
+            <a:picLocks noChangeAspect="1"/>
+          </p:cNvPicPr>
+          <p:nvPr/>
+        </p:nvPicPr>
+        <p:blipFill>
+          <a:blip r:embed="rId5"/>
+          <a:stretch>
+            <a:fillRect/>
+          </a:stretch>
+        </p:blipFill>
+        <p:spPr>
+          <a:xfrm>
+            <a:off x="10554730" y="6336792"/>
+            <a:ext cx="622780" cy="384048"/>
           </a:xfrm>
           <a:prstGeom prst="rect">
             <a:avLst/>
@@ -2781,11 +3233,11 @@
             <a:r>
               <a:rPr lang="en-US" sz="2600" b="1" dirty="0">
                 <a:solidFill>
-                  <a:srgbClr val="15253D"/>
+                  <a:srgbClr val="2B1638"/>
                 </a:solidFill>
-                <a:latin typeface="Arial" pitchFamily="34" charset="0"/>
-                <a:ea typeface="Arial" pitchFamily="34" charset="-122"/>
-                <a:cs typeface="Arial" pitchFamily="34" charset="-120"/>
+                <a:latin typeface="Liberation Serif" pitchFamily="34" charset="0"/>
+                <a:ea typeface="Liberation Serif" pitchFamily="34" charset="-122"/>
+                <a:cs typeface="Liberation Serif" pitchFamily="34" charset="-120"/>
               </a:rPr>
               <a:t>What changed</a:t>
             </a:r>
@@ -2850,7 +3302,7 @@
                   <a:tcPr marL="109728" marR="109728" marT="109728" marB="109728" anchor="ctr">
                     <a:lnL w="9525" cap="flat" cmpd="sng" algn="ctr">
                       <a:solidFill>
-                        <a:srgbClr val="D5DDE8"/>
+                        <a:srgbClr val="EBD8EE"/>
                       </a:solidFill>
                       <a:prstDash val="solid"/>
                       <a:round/>
@@ -2859,7 +3311,7 @@
                     </a:lnL>
                     <a:lnR w="9525" cap="flat" cmpd="sng" algn="ctr">
                       <a:solidFill>
-                        <a:srgbClr val="D5DDE8"/>
+                        <a:srgbClr val="EBD8EE"/>
                       </a:solidFill>
                       <a:prstDash val="solid"/>
                       <a:round/>
@@ -2868,7 +3320,7 @@
                     </a:lnR>
                     <a:lnT w="9525" cap="flat" cmpd="sng" algn="ctr">
                       <a:solidFill>
-                        <a:srgbClr val="D5DDE8"/>
+                        <a:srgbClr val="EBD8EE"/>
                       </a:solidFill>
                       <a:prstDash val="solid"/>
                       <a:round/>
@@ -2877,7 +3329,7 @@
                     </a:lnT>
                     <a:lnB w="9525" cap="flat" cmpd="sng" algn="ctr">
                       <a:solidFill>
-                        <a:srgbClr val="D5DDE8"/>
+                        <a:srgbClr val="EBD8EE"/>
                       </a:solidFill>
                       <a:prstDash val="solid"/>
                       <a:round/>
@@ -2885,7 +3337,7 @@
                       <a:tailEnd type="none" w="med" len="med"/>
                     </a:lnB>
                     <a:solidFill>
-                      <a:srgbClr val="15253D"/>
+                      <a:srgbClr val="2B1638"/>
                     </a:solidFill>
                   </a:tcPr>
                 </a:tc>
@@ -2918,7 +3370,7 @@
                   <a:tcPr marL="109728" marR="109728" marT="109728" marB="109728" anchor="ctr">
                     <a:lnL w="9525" cap="flat" cmpd="sng" algn="ctr">
                       <a:solidFill>
-                        <a:srgbClr val="D5DDE8"/>
+                        <a:srgbClr val="EBD8EE"/>
                       </a:solidFill>
                       <a:prstDash val="solid"/>
                       <a:round/>
@@ -2927,7 +3379,7 @@
                     </a:lnL>
                     <a:lnR w="9525" cap="flat" cmpd="sng" algn="ctr">
                       <a:solidFill>
-                        <a:srgbClr val="D5DDE8"/>
+                        <a:srgbClr val="EBD8EE"/>
                       </a:solidFill>
                       <a:prstDash val="solid"/>
                       <a:round/>
@@ -2936,7 +3388,7 @@
                     </a:lnR>
                     <a:lnT w="9525" cap="flat" cmpd="sng" algn="ctr">
                       <a:solidFill>
-                        <a:srgbClr val="D5DDE8"/>
+                        <a:srgbClr val="EBD8EE"/>
                       </a:solidFill>
                       <a:prstDash val="solid"/>
                       <a:round/>
@@ -2945,7 +3397,7 @@
                     </a:lnT>
                     <a:lnB w="9525" cap="flat" cmpd="sng" algn="ctr">
                       <a:solidFill>
-                        <a:srgbClr val="D5DDE8"/>
+                        <a:srgbClr val="EBD8EE"/>
                       </a:solidFill>
                       <a:prstDash val="solid"/>
                       <a:round/>
@@ -2953,7 +3405,7 @@
                       <a:tailEnd type="none" w="med" len="med"/>
                     </a:lnB>
                     <a:solidFill>
-                      <a:srgbClr val="15253D"/>
+                      <a:srgbClr val="2B1638"/>
                     </a:solidFill>
                   </a:tcPr>
                 </a:tc>
@@ -2986,7 +3438,7 @@
                   <a:tcPr marL="109728" marR="109728" marT="109728" marB="109728" anchor="ctr">
                     <a:lnL w="9525" cap="flat" cmpd="sng" algn="ctr">
                       <a:solidFill>
-                        <a:srgbClr val="D5DDE8"/>
+                        <a:srgbClr val="EBD8EE"/>
                       </a:solidFill>
                       <a:prstDash val="solid"/>
                       <a:round/>
@@ -2995,7 +3447,7 @@
                     </a:lnL>
                     <a:lnR w="9525" cap="flat" cmpd="sng" algn="ctr">
                       <a:solidFill>
-                        <a:srgbClr val="D5DDE8"/>
+                        <a:srgbClr val="EBD8EE"/>
                       </a:solidFill>
                       <a:prstDash val="solid"/>
                       <a:round/>
@@ -3004,7 +3456,7 @@
                     </a:lnR>
                     <a:lnT w="9525" cap="flat" cmpd="sng" algn="ctr">
                       <a:solidFill>
-                        <a:srgbClr val="D5DDE8"/>
+                        <a:srgbClr val="EBD8EE"/>
                       </a:solidFill>
                       <a:prstDash val="solid"/>
                       <a:round/>
@@ -3013,7 +3465,7 @@
                     </a:lnT>
                     <a:lnB w="9525" cap="flat" cmpd="sng" algn="ctr">
                       <a:solidFill>
-                        <a:srgbClr val="D5DDE8"/>
+                        <a:srgbClr val="EBD8EE"/>
                       </a:solidFill>
                       <a:prstDash val="solid"/>
                       <a:round/>
@@ -3021,7 +3473,7 @@
                       <a:tailEnd type="none" w="med" len="med"/>
                     </a:lnB>
                     <a:solidFill>
-                      <a:srgbClr val="15253D"/>
+                      <a:srgbClr val="2B1638"/>
                     </a:solidFill>
                   </a:tcPr>
                 </a:tc>
@@ -3038,7 +3490,7 @@
                       <a:r>
                         <a:rPr lang="en-US" sz="1500" b="1" dirty="0">
                           <a:solidFill>
-                            <a:srgbClr val="0F766E"/>
+                            <a:srgbClr val="8E24D9"/>
                           </a:solidFill>
                           <a:latin typeface="Arial" pitchFamily="34" charset="0"/>
                           <a:ea typeface="Arial" pitchFamily="34" charset="-122"/>
@@ -3056,7 +3508,7 @@
                   <a:tcPr marL="109728" marR="109728" marT="109728" marB="109728" anchor="ctr">
                     <a:lnL w="9525" cap="flat" cmpd="sng" algn="ctr">
                       <a:solidFill>
-                        <a:srgbClr val="D5DDE8"/>
+                        <a:srgbClr val="EBD8EE"/>
                       </a:solidFill>
                       <a:prstDash val="solid"/>
                       <a:round/>
@@ -3065,7 +3517,7 @@
                     </a:lnL>
                     <a:lnR w="9525" cap="flat" cmpd="sng" algn="ctr">
                       <a:solidFill>
-                        <a:srgbClr val="D5DDE8"/>
+                        <a:srgbClr val="EBD8EE"/>
                       </a:solidFill>
                       <a:prstDash val="solid"/>
                       <a:round/>
@@ -3074,7 +3526,7 @@
                     </a:lnR>
                     <a:lnT w="9525" cap="flat" cmpd="sng" algn="ctr">
                       <a:solidFill>
-                        <a:srgbClr val="D5DDE8"/>
+                        <a:srgbClr val="EBD8EE"/>
                       </a:solidFill>
                       <a:prstDash val="solid"/>
                       <a:round/>
@@ -3083,7 +3535,7 @@
                     </a:lnT>
                     <a:lnB w="9525" cap="flat" cmpd="sng" algn="ctr">
                       <a:solidFill>
-                        <a:srgbClr val="D5DDE8"/>
+                        <a:srgbClr val="EBD8EE"/>
                       </a:solidFill>
                       <a:prstDash val="solid"/>
                       <a:round/>
@@ -3091,7 +3543,7 @@
                       <a:tailEnd type="none" w="med" len="med"/>
                     </a:lnB>
                     <a:solidFill>
-                      <a:srgbClr val="F4F7FB"/>
+                      <a:srgbClr val="FBF5FB"/>
                     </a:solidFill>
                   </a:tcPr>
                 </a:tc>
@@ -3124,7 +3576,7 @@
                   <a:tcPr marL="109728" marR="109728" marT="109728" marB="109728" anchor="ctr">
                     <a:lnL w="9525" cap="flat" cmpd="sng" algn="ctr">
                       <a:solidFill>
-                        <a:srgbClr val="D5DDE8"/>
+                        <a:srgbClr val="EBD8EE"/>
                       </a:solidFill>
                       <a:prstDash val="solid"/>
                       <a:round/>
@@ -3133,7 +3585,7 @@
                     </a:lnL>
                     <a:lnR w="9525" cap="flat" cmpd="sng" algn="ctr">
                       <a:solidFill>
-                        <a:srgbClr val="D5DDE8"/>
+                        <a:srgbClr val="EBD8EE"/>
                       </a:solidFill>
                       <a:prstDash val="solid"/>
                       <a:round/>
@@ -3142,7 +3594,7 @@
                     </a:lnR>
                     <a:lnT w="9525" cap="flat" cmpd="sng" algn="ctr">
                       <a:solidFill>
-                        <a:srgbClr val="D5DDE8"/>
+                        <a:srgbClr val="EBD8EE"/>
                       </a:solidFill>
                       <a:prstDash val="solid"/>
                       <a:round/>
@@ -3151,7 +3603,7 @@
                     </a:lnT>
                     <a:lnB w="9525" cap="flat" cmpd="sng" algn="ctr">
                       <a:solidFill>
-                        <a:srgbClr val="D5DDE8"/>
+                        <a:srgbClr val="EBD8EE"/>
                       </a:solidFill>
                       <a:prstDash val="solid"/>
                       <a:round/>
@@ -3159,7 +3611,7 @@
                       <a:tailEnd type="none" w="med" len="med"/>
                     </a:lnB>
                     <a:solidFill>
-                      <a:srgbClr val="F4F7FB"/>
+                      <a:srgbClr val="FBF5FB"/>
                     </a:solidFill>
                   </a:tcPr>
                 </a:tc>
@@ -3192,7 +3644,7 @@
                   <a:tcPr marL="109728" marR="109728" marT="109728" marB="109728" anchor="ctr">
                     <a:lnL w="9525" cap="flat" cmpd="sng" algn="ctr">
                       <a:solidFill>
-                        <a:srgbClr val="D5DDE8"/>
+                        <a:srgbClr val="EBD8EE"/>
                       </a:solidFill>
                       <a:prstDash val="solid"/>
                       <a:round/>
@@ -3201,7 +3653,7 @@
                     </a:lnL>
                     <a:lnR w="9525" cap="flat" cmpd="sng" algn="ctr">
                       <a:solidFill>
-                        <a:srgbClr val="D5DDE8"/>
+                        <a:srgbClr val="EBD8EE"/>
                       </a:solidFill>
                       <a:prstDash val="solid"/>
                       <a:round/>
@@ -3210,7 +3662,7 @@
                     </a:lnR>
                     <a:lnT w="9525" cap="flat" cmpd="sng" algn="ctr">
                       <a:solidFill>
-                        <a:srgbClr val="D5DDE8"/>
+                        <a:srgbClr val="EBD8EE"/>
                       </a:solidFill>
                       <a:prstDash val="solid"/>
                       <a:round/>
@@ -3219,7 +3671,7 @@
                     </a:lnT>
                     <a:lnB w="9525" cap="flat" cmpd="sng" algn="ctr">
                       <a:solidFill>
-                        <a:srgbClr val="D5DDE8"/>
+                        <a:srgbClr val="EBD8EE"/>
                       </a:solidFill>
                       <a:prstDash val="solid"/>
                       <a:round/>
@@ -3227,7 +3679,7 @@
                       <a:tailEnd type="none" w="med" len="med"/>
                     </a:lnB>
                     <a:solidFill>
-                      <a:srgbClr val="F4F7FB"/>
+                      <a:srgbClr val="FBF5FB"/>
                     </a:solidFill>
                   </a:tcPr>
                 </a:tc>
@@ -3244,7 +3696,7 @@
                       <a:r>
                         <a:rPr lang="en-US" sz="1500" b="1" dirty="0">
                           <a:solidFill>
-                            <a:srgbClr val="0F766E"/>
+                            <a:srgbClr val="8E24D9"/>
                           </a:solidFill>
                           <a:latin typeface="Arial" pitchFamily="34" charset="0"/>
                           <a:ea typeface="Arial" pitchFamily="34" charset="-122"/>
@@ -3262,7 +3714,7 @@
                   <a:tcPr marL="109728" marR="109728" marT="109728" marB="109728" anchor="ctr">
                     <a:lnL w="9525" cap="flat" cmpd="sng" algn="ctr">
                       <a:solidFill>
-                        <a:srgbClr val="D5DDE8"/>
+                        <a:srgbClr val="EBD8EE"/>
                       </a:solidFill>
                       <a:prstDash val="solid"/>
                       <a:round/>
@@ -3271,7 +3723,7 @@
                     </a:lnL>
                     <a:lnR w="9525" cap="flat" cmpd="sng" algn="ctr">
                       <a:solidFill>
-                        <a:srgbClr val="D5DDE8"/>
+                        <a:srgbClr val="EBD8EE"/>
                       </a:solidFill>
                       <a:prstDash val="solid"/>
                       <a:round/>
@@ -3280,7 +3732,7 @@
                     </a:lnR>
                     <a:lnT w="9525" cap="flat" cmpd="sng" algn="ctr">
                       <a:solidFill>
-                        <a:srgbClr val="D5DDE8"/>
+                        <a:srgbClr val="EBD8EE"/>
                       </a:solidFill>
                       <a:prstDash val="solid"/>
                       <a:round/>
@@ -3289,7 +3741,7 @@
                     </a:lnT>
                     <a:lnB w="9525" cap="flat" cmpd="sng" algn="ctr">
                       <a:solidFill>
-                        <a:srgbClr val="D5DDE8"/>
+                        <a:srgbClr val="EBD8EE"/>
                       </a:solidFill>
                       <a:prstDash val="solid"/>
                       <a:round/>
@@ -3330,7 +3782,7 @@
                   <a:tcPr marL="109728" marR="109728" marT="109728" marB="109728" anchor="ctr">
                     <a:lnL w="9525" cap="flat" cmpd="sng" algn="ctr">
                       <a:solidFill>
-                        <a:srgbClr val="D5DDE8"/>
+                        <a:srgbClr val="EBD8EE"/>
                       </a:solidFill>
                       <a:prstDash val="solid"/>
                       <a:round/>
@@ -3339,7 +3791,7 @@
                     </a:lnL>
                     <a:lnR w="9525" cap="flat" cmpd="sng" algn="ctr">
                       <a:solidFill>
-                        <a:srgbClr val="D5DDE8"/>
+                        <a:srgbClr val="EBD8EE"/>
                       </a:solidFill>
                       <a:prstDash val="solid"/>
                       <a:round/>
@@ -3348,7 +3800,7 @@
                     </a:lnR>
                     <a:lnT w="9525" cap="flat" cmpd="sng" algn="ctr">
                       <a:solidFill>
-                        <a:srgbClr val="D5DDE8"/>
+                        <a:srgbClr val="EBD8EE"/>
                       </a:solidFill>
                       <a:prstDash val="solid"/>
                       <a:round/>
@@ -3357,7 +3809,7 @@
                     </a:lnT>
                     <a:lnB w="9525" cap="flat" cmpd="sng" algn="ctr">
                       <a:solidFill>
-                        <a:srgbClr val="D5DDE8"/>
+                        <a:srgbClr val="EBD8EE"/>
                       </a:solidFill>
                       <a:prstDash val="solid"/>
                       <a:round/>
@@ -3398,7 +3850,7 @@
                   <a:tcPr marL="109728" marR="109728" marT="109728" marB="109728" anchor="ctr">
                     <a:lnL w="9525" cap="flat" cmpd="sng" algn="ctr">
                       <a:solidFill>
-                        <a:srgbClr val="D5DDE8"/>
+                        <a:srgbClr val="EBD8EE"/>
                       </a:solidFill>
                       <a:prstDash val="solid"/>
                       <a:round/>
@@ -3407,7 +3859,7 @@
                     </a:lnL>
                     <a:lnR w="9525" cap="flat" cmpd="sng" algn="ctr">
                       <a:solidFill>
-                        <a:srgbClr val="D5DDE8"/>
+                        <a:srgbClr val="EBD8EE"/>
                       </a:solidFill>
                       <a:prstDash val="solid"/>
                       <a:round/>
@@ -3416,7 +3868,7 @@
                     </a:lnR>
                     <a:lnT w="9525" cap="flat" cmpd="sng" algn="ctr">
                       <a:solidFill>
-                        <a:srgbClr val="D5DDE8"/>
+                        <a:srgbClr val="EBD8EE"/>
                       </a:solidFill>
                       <a:prstDash val="solid"/>
                       <a:round/>
@@ -3425,7 +3877,7 @@
                     </a:lnT>
                     <a:lnB w="9525" cap="flat" cmpd="sng" algn="ctr">
                       <a:solidFill>
-                        <a:srgbClr val="D5DDE8"/>
+                        <a:srgbClr val="EBD8EE"/>
                       </a:solidFill>
                       <a:prstDash val="solid"/>
                       <a:round/>
@@ -3450,7 +3902,7 @@
                       <a:r>
                         <a:rPr lang="en-US" sz="1500" b="1" dirty="0">
                           <a:solidFill>
-                            <a:srgbClr val="0F766E"/>
+                            <a:srgbClr val="8E24D9"/>
                           </a:solidFill>
                           <a:latin typeface="Arial" pitchFamily="34" charset="0"/>
                           <a:ea typeface="Arial" pitchFamily="34" charset="-122"/>
@@ -3468,7 +3920,7 @@
                   <a:tcPr marL="109728" marR="109728" marT="109728" marB="109728" anchor="ctr">
                     <a:lnL w="9525" cap="flat" cmpd="sng" algn="ctr">
                       <a:solidFill>
-                        <a:srgbClr val="D5DDE8"/>
+                        <a:srgbClr val="EBD8EE"/>
                       </a:solidFill>
                       <a:prstDash val="solid"/>
                       <a:round/>
@@ -3477,7 +3929,7 @@
                     </a:lnL>
                     <a:lnR w="9525" cap="flat" cmpd="sng" algn="ctr">
                       <a:solidFill>
-                        <a:srgbClr val="D5DDE8"/>
+                        <a:srgbClr val="EBD8EE"/>
                       </a:solidFill>
                       <a:prstDash val="solid"/>
                       <a:round/>
@@ -3486,7 +3938,7 @@
                     </a:lnR>
                     <a:lnT w="9525" cap="flat" cmpd="sng" algn="ctr">
                       <a:solidFill>
-                        <a:srgbClr val="D5DDE8"/>
+                        <a:srgbClr val="EBD8EE"/>
                       </a:solidFill>
                       <a:prstDash val="solid"/>
                       <a:round/>
@@ -3495,7 +3947,7 @@
                     </a:lnT>
                     <a:lnB w="9525" cap="flat" cmpd="sng" algn="ctr">
                       <a:solidFill>
-                        <a:srgbClr val="D5DDE8"/>
+                        <a:srgbClr val="EBD8EE"/>
                       </a:solidFill>
                       <a:prstDash val="solid"/>
                       <a:round/>
@@ -3503,7 +3955,7 @@
                       <a:tailEnd type="none" w="med" len="med"/>
                     </a:lnB>
                     <a:solidFill>
-                      <a:srgbClr val="F4F7FB"/>
+                      <a:srgbClr val="FBF5FB"/>
                     </a:solidFill>
                   </a:tcPr>
                 </a:tc>
@@ -3536,7 +3988,7 @@
                   <a:tcPr marL="109728" marR="109728" marT="109728" marB="109728" anchor="ctr">
                     <a:lnL w="9525" cap="flat" cmpd="sng" algn="ctr">
                       <a:solidFill>
-                        <a:srgbClr val="D5DDE8"/>
+                        <a:srgbClr val="EBD8EE"/>
                       </a:solidFill>
                       <a:prstDash val="solid"/>
                       <a:round/>
@@ -3545,7 +3997,7 @@
                     </a:lnL>
                     <a:lnR w="9525" cap="flat" cmpd="sng" algn="ctr">
                       <a:solidFill>
-                        <a:srgbClr val="D5DDE8"/>
+                        <a:srgbClr val="EBD8EE"/>
                       </a:solidFill>
                       <a:prstDash val="solid"/>
                       <a:round/>
@@ -3554,7 +4006,7 @@
                     </a:lnR>
                     <a:lnT w="9525" cap="flat" cmpd="sng" algn="ctr">
                       <a:solidFill>
-                        <a:srgbClr val="D5DDE8"/>
+                        <a:srgbClr val="EBD8EE"/>
                       </a:solidFill>
                       <a:prstDash val="solid"/>
                       <a:round/>
@@ -3563,7 +4015,7 @@
                     </a:lnT>
                     <a:lnB w="9525" cap="flat" cmpd="sng" algn="ctr">
                       <a:solidFill>
-                        <a:srgbClr val="D5DDE8"/>
+                        <a:srgbClr val="EBD8EE"/>
                       </a:solidFill>
                       <a:prstDash val="solid"/>
                       <a:round/>
@@ -3571,7 +4023,7 @@
                       <a:tailEnd type="none" w="med" len="med"/>
                     </a:lnB>
                     <a:solidFill>
-                      <a:srgbClr val="F4F7FB"/>
+                      <a:srgbClr val="FBF5FB"/>
                     </a:solidFill>
                   </a:tcPr>
                 </a:tc>
@@ -3604,7 +4056,7 @@
                   <a:tcPr marL="109728" marR="109728" marT="109728" marB="109728" anchor="ctr">
                     <a:lnL w="9525" cap="flat" cmpd="sng" algn="ctr">
                       <a:solidFill>
-                        <a:srgbClr val="D5DDE8"/>
+                        <a:srgbClr val="EBD8EE"/>
                       </a:solidFill>
                       <a:prstDash val="solid"/>
                       <a:round/>
@@ -3613,7 +4065,7 @@
                     </a:lnL>
                     <a:lnR w="9525" cap="flat" cmpd="sng" algn="ctr">
                       <a:solidFill>
-                        <a:srgbClr val="D5DDE8"/>
+                        <a:srgbClr val="EBD8EE"/>
                       </a:solidFill>
                       <a:prstDash val="solid"/>
                       <a:round/>
@@ -3622,7 +4074,7 @@
                     </a:lnR>
                     <a:lnT w="9525" cap="flat" cmpd="sng" algn="ctr">
                       <a:solidFill>
-                        <a:srgbClr val="D5DDE8"/>
+                        <a:srgbClr val="EBD8EE"/>
                       </a:solidFill>
                       <a:prstDash val="solid"/>
                       <a:round/>
@@ -3631,7 +4083,7 @@
                     </a:lnT>
                     <a:lnB w="9525" cap="flat" cmpd="sng" algn="ctr">
                       <a:solidFill>
-                        <a:srgbClr val="D5DDE8"/>
+                        <a:srgbClr val="EBD8EE"/>
                       </a:solidFill>
                       <a:prstDash val="solid"/>
                       <a:round/>
@@ -3639,7 +4091,7 @@
                       <a:tailEnd type="none" w="med" len="med"/>
                     </a:lnB>
                     <a:solidFill>
-                      <a:srgbClr val="F4F7FB"/>
+                      <a:srgbClr val="FBF5FB"/>
                     </a:solidFill>
                   </a:tcPr>
                 </a:tc>
@@ -3656,7 +4108,7 @@
                       <a:r>
                         <a:rPr lang="en-US" sz="1500" b="1" dirty="0">
                           <a:solidFill>
-                            <a:srgbClr val="0F766E"/>
+                            <a:srgbClr val="8E24D9"/>
                           </a:solidFill>
                           <a:latin typeface="Arial" pitchFamily="34" charset="0"/>
                           <a:ea typeface="Arial" pitchFamily="34" charset="-122"/>
@@ -3674,7 +4126,7 @@
                   <a:tcPr marL="109728" marR="109728" marT="109728" marB="109728" anchor="ctr">
                     <a:lnL w="9525" cap="flat" cmpd="sng" algn="ctr">
                       <a:solidFill>
-                        <a:srgbClr val="D5DDE8"/>
+                        <a:srgbClr val="EBD8EE"/>
                       </a:solidFill>
                       <a:prstDash val="solid"/>
                       <a:round/>
@@ -3683,7 +4135,7 @@
                     </a:lnL>
                     <a:lnR w="9525" cap="flat" cmpd="sng" algn="ctr">
                       <a:solidFill>
-                        <a:srgbClr val="D5DDE8"/>
+                        <a:srgbClr val="EBD8EE"/>
                       </a:solidFill>
                       <a:prstDash val="solid"/>
                       <a:round/>
@@ -3692,7 +4144,7 @@
                     </a:lnR>
                     <a:lnT w="9525" cap="flat" cmpd="sng" algn="ctr">
                       <a:solidFill>
-                        <a:srgbClr val="D5DDE8"/>
+                        <a:srgbClr val="EBD8EE"/>
                       </a:solidFill>
                       <a:prstDash val="solid"/>
                       <a:round/>
@@ -3701,7 +4153,7 @@
                     </a:lnT>
                     <a:lnB w="9525" cap="flat" cmpd="sng" algn="ctr">
                       <a:solidFill>
-                        <a:srgbClr val="D5DDE8"/>
+                        <a:srgbClr val="EBD8EE"/>
                       </a:solidFill>
                       <a:prstDash val="solid"/>
                       <a:round/>
@@ -3742,7 +4194,7 @@
                   <a:tcPr marL="109728" marR="109728" marT="109728" marB="109728" anchor="ctr">
                     <a:lnL w="9525" cap="flat" cmpd="sng" algn="ctr">
                       <a:solidFill>
-                        <a:srgbClr val="D5DDE8"/>
+                        <a:srgbClr val="EBD8EE"/>
                       </a:solidFill>
                       <a:prstDash val="solid"/>
                       <a:round/>
@@ -3751,7 +4203,7 @@
                     </a:lnL>
                     <a:lnR w="9525" cap="flat" cmpd="sng" algn="ctr">
                       <a:solidFill>
-                        <a:srgbClr val="D5DDE8"/>
+                        <a:srgbClr val="EBD8EE"/>
                       </a:solidFill>
                       <a:prstDash val="solid"/>
                       <a:round/>
@@ -3760,7 +4212,7 @@
                     </a:lnR>
                     <a:lnT w="9525" cap="flat" cmpd="sng" algn="ctr">
                       <a:solidFill>
-                        <a:srgbClr val="D5DDE8"/>
+                        <a:srgbClr val="EBD8EE"/>
                       </a:solidFill>
                       <a:prstDash val="solid"/>
                       <a:round/>
@@ -3769,7 +4221,7 @@
                     </a:lnT>
                     <a:lnB w="9525" cap="flat" cmpd="sng" algn="ctr">
                       <a:solidFill>
-                        <a:srgbClr val="D5DDE8"/>
+                        <a:srgbClr val="EBD8EE"/>
                       </a:solidFill>
                       <a:prstDash val="solid"/>
                       <a:round/>
@@ -3810,7 +4262,7 @@
                   <a:tcPr marL="109728" marR="109728" marT="109728" marB="109728" anchor="ctr">
                     <a:lnL w="9525" cap="flat" cmpd="sng" algn="ctr">
                       <a:solidFill>
-                        <a:srgbClr val="D5DDE8"/>
+                        <a:srgbClr val="EBD8EE"/>
                       </a:solidFill>
                       <a:prstDash val="solid"/>
                       <a:round/>
@@ -3819,7 +4271,7 @@
                     </a:lnL>
                     <a:lnR w="9525" cap="flat" cmpd="sng" algn="ctr">
                       <a:solidFill>
-                        <a:srgbClr val="D5DDE8"/>
+                        <a:srgbClr val="EBD8EE"/>
                       </a:solidFill>
                       <a:prstDash val="solid"/>
                       <a:round/>
@@ -3828,7 +4280,7 @@
                     </a:lnR>
                     <a:lnT w="9525" cap="flat" cmpd="sng" algn="ctr">
                       <a:solidFill>
-                        <a:srgbClr val="D5DDE8"/>
+                        <a:srgbClr val="EBD8EE"/>
                       </a:solidFill>
                       <a:prstDash val="solid"/>
                       <a:round/>
@@ -3837,7 +4289,7 @@
                     </a:lnT>
                     <a:lnB w="9525" cap="flat" cmpd="sng" algn="ctr">
                       <a:solidFill>
-                        <a:srgbClr val="D5DDE8"/>
+                        <a:srgbClr val="EBD8EE"/>
                       </a:solidFill>
                       <a:prstDash val="solid"/>
                       <a:round/>
@@ -3932,6 +4384,118 @@
           </a:p>
         </p:txBody>
       </p:sp>
+      <p:sp>
+        <p:nvSpPr>
+          <p:cNvPr id="7" name="Rectangle 6"/>
+          <p:cNvSpPr/>
+          <p:nvPr/>
+        </p:nvSpPr>
+        <p:spPr>
+          <a:xfrm>
+            <a:off x="0" y="0"/>
+            <a:ext cx="12192000" cy="82296"/>
+          </a:xfrm>
+          <a:prstGeom prst="rect">
+            <a:avLst/>
+          </a:prstGeom>
+          <a:solidFill>
+            <a:srgbClr val="2B1638"/>
+          </a:solidFill>
+          <a:ln>
+            <a:noFill/>
+          </a:ln>
+          <a:effectLst/>
+        </p:spPr>
+        <p:style>
+          <a:lnRef idx="1">
+            <a:schemeClr val="accent1"/>
+          </a:lnRef>
+          <a:fillRef idx="3">
+            <a:schemeClr val="accent1"/>
+          </a:fillRef>
+          <a:effectRef idx="2">
+            <a:schemeClr val="accent1"/>
+          </a:effectRef>
+          <a:fontRef idx="minor">
+            <a:schemeClr val="lt1"/>
+          </a:fontRef>
+        </p:style>
+        <p:txBody>
+          <a:bodyPr rtlCol="0" anchor="ctr"/>
+          <a:lstStyle/>
+          <a:p>
+            <a:pPr algn="ctr"/>
+          </a:p>
+        </p:txBody>
+      </p:sp>
+      <p:sp>
+        <p:nvSpPr>
+          <p:cNvPr id="8" name="Rectangle 7"/>
+          <p:cNvSpPr/>
+          <p:nvPr/>
+        </p:nvSpPr>
+        <p:spPr>
+          <a:xfrm>
+            <a:off x="0" y="82296"/>
+            <a:ext cx="1463040" cy="45720"/>
+          </a:xfrm>
+          <a:prstGeom prst="rect">
+            <a:avLst/>
+          </a:prstGeom>
+          <a:solidFill>
+            <a:srgbClr val="A020F0"/>
+          </a:solidFill>
+          <a:ln>
+            <a:noFill/>
+          </a:ln>
+          <a:effectLst/>
+        </p:spPr>
+        <p:style>
+          <a:lnRef idx="1">
+            <a:schemeClr val="accent1"/>
+          </a:lnRef>
+          <a:fillRef idx="3">
+            <a:schemeClr val="accent1"/>
+          </a:fillRef>
+          <a:effectRef idx="2">
+            <a:schemeClr val="accent1"/>
+          </a:effectRef>
+          <a:fontRef idx="minor">
+            <a:schemeClr val="lt1"/>
+          </a:fontRef>
+        </p:style>
+        <p:txBody>
+          <a:bodyPr rtlCol="0" anchor="ctr"/>
+          <a:lstStyle/>
+          <a:p>
+            <a:pPr algn="ctr"/>
+          </a:p>
+        </p:txBody>
+      </p:sp>
+      <p:pic>
+        <p:nvPicPr>
+          <p:cNvPr id="9" name="Picture 8" descr="kom_logo.png"/>
+          <p:cNvPicPr>
+            <a:picLocks noChangeAspect="1"/>
+          </p:cNvPicPr>
+          <p:nvPr/>
+        </p:nvPicPr>
+        <p:blipFill>
+          <a:blip r:embed="rId3"/>
+          <a:stretch>
+            <a:fillRect/>
+          </a:stretch>
+        </p:blipFill>
+        <p:spPr>
+          <a:xfrm>
+            <a:off x="10554730" y="6336792"/>
+            <a:ext cx="622780" cy="384048"/>
+          </a:xfrm>
+          <a:prstGeom prst="rect">
+            <a:avLst/>
+          </a:prstGeom>
+        </p:spPr>
+      </p:pic>
     </p:spTree>
   </p:cSld>
   <p:clrMapOvr>
@@ -3991,11 +4555,11 @@
             <a:r>
               <a:rPr lang="en-US" sz="2600" b="1" dirty="0">
                 <a:solidFill>
-                  <a:srgbClr val="15253D"/>
+                  <a:srgbClr val="2B1638"/>
                 </a:solidFill>
-                <a:latin typeface="Arial" pitchFamily="34" charset="0"/>
-                <a:ea typeface="Arial" pitchFamily="34" charset="-122"/>
-                <a:cs typeface="Arial" pitchFamily="34" charset="-120"/>
+                <a:latin typeface="Liberation Serif" pitchFamily="34" charset="0"/>
+                <a:ea typeface="Liberation Serif" pitchFamily="34" charset="-122"/>
+                <a:cs typeface="Liberation Serif" pitchFamily="34" charset="-120"/>
               </a:rPr>
               <a:t>Delivered outcomes</a:t>
             </a:r>
@@ -4057,11 +4621,11 @@
             <a:avLst/>
           </a:prstGeom>
           <a:solidFill>
-            <a:srgbClr val="F4F7FB"/>
+            <a:srgbClr val="FBF5FB"/>
           </a:solidFill>
           <a:ln w="12700">
             <a:solidFill>
-              <a:srgbClr val="F4F7FB"/>
+              <a:srgbClr val="FBF5FB"/>
             </a:solidFill>
             <a:prstDash val="solid"/>
           </a:ln>
@@ -4098,11 +4662,11 @@
             <a:r>
               <a:rPr lang="en-US" sz="7200" b="1" dirty="0">
                 <a:solidFill>
-                  <a:srgbClr val="0F766E"/>
+                  <a:srgbClr val="8E24D9"/>
                 </a:solidFill>
-                <a:latin typeface="Arial" pitchFamily="34" charset="0"/>
-                <a:ea typeface="Arial" pitchFamily="34" charset="-122"/>
-                <a:cs typeface="Arial" pitchFamily="34" charset="-120"/>
+                <a:latin typeface="Liberation Serif" pitchFamily="34" charset="0"/>
+                <a:ea typeface="Liberation Serif" pitchFamily="34" charset="-122"/>
+                <a:cs typeface="Liberation Serif" pitchFamily="34" charset="-120"/>
               </a:rPr>
               <a:t>14</a:t>
             </a:r>
@@ -4164,11 +4728,11 @@
             <a:avLst/>
           </a:prstGeom>
           <a:solidFill>
-            <a:srgbClr val="F4F7FB"/>
+            <a:srgbClr val="FBF5FB"/>
           </a:solidFill>
           <a:ln w="12700">
             <a:solidFill>
-              <a:srgbClr val="F4F7FB"/>
+              <a:srgbClr val="FBF5FB"/>
             </a:solidFill>
             <a:prstDash val="solid"/>
           </a:ln>
@@ -4205,11 +4769,11 @@
             <a:r>
               <a:rPr lang="en-US" sz="7200" b="1" dirty="0">
                 <a:solidFill>
-                  <a:srgbClr val="0F766E"/>
+                  <a:srgbClr val="8E24D9"/>
                 </a:solidFill>
-                <a:latin typeface="Arial" pitchFamily="34" charset="0"/>
-                <a:ea typeface="Arial" pitchFamily="34" charset="-122"/>
-                <a:cs typeface="Arial" pitchFamily="34" charset="-120"/>
+                <a:latin typeface="Liberation Serif" pitchFamily="34" charset="0"/>
+                <a:ea typeface="Liberation Serif" pitchFamily="34" charset="-122"/>
+                <a:cs typeface="Liberation Serif" pitchFamily="34" charset="-120"/>
               </a:rPr>
               <a:t>4 months</a:t>
             </a:r>
@@ -4334,6 +4898,118 @@
           </a:p>
         </p:txBody>
       </p:sp>
+      <p:sp>
+        <p:nvSpPr>
+          <p:cNvPr id="12" name="Rectangle 11"/>
+          <p:cNvSpPr/>
+          <p:nvPr/>
+        </p:nvSpPr>
+        <p:spPr>
+          <a:xfrm>
+            <a:off x="0" y="0"/>
+            <a:ext cx="12192000" cy="82296"/>
+          </a:xfrm>
+          <a:prstGeom prst="rect">
+            <a:avLst/>
+          </a:prstGeom>
+          <a:solidFill>
+            <a:srgbClr val="2B1638"/>
+          </a:solidFill>
+          <a:ln>
+            <a:noFill/>
+          </a:ln>
+          <a:effectLst/>
+        </p:spPr>
+        <p:style>
+          <a:lnRef idx="1">
+            <a:schemeClr val="accent1"/>
+          </a:lnRef>
+          <a:fillRef idx="3">
+            <a:schemeClr val="accent1"/>
+          </a:fillRef>
+          <a:effectRef idx="2">
+            <a:schemeClr val="accent1"/>
+          </a:effectRef>
+          <a:fontRef idx="minor">
+            <a:schemeClr val="lt1"/>
+          </a:fontRef>
+        </p:style>
+        <p:txBody>
+          <a:bodyPr rtlCol="0" anchor="ctr"/>
+          <a:lstStyle/>
+          <a:p>
+            <a:pPr algn="ctr"/>
+          </a:p>
+        </p:txBody>
+      </p:sp>
+      <p:sp>
+        <p:nvSpPr>
+          <p:cNvPr id="13" name="Rectangle 12"/>
+          <p:cNvSpPr/>
+          <p:nvPr/>
+        </p:nvSpPr>
+        <p:spPr>
+          <a:xfrm>
+            <a:off x="0" y="82296"/>
+            <a:ext cx="1463040" cy="45720"/>
+          </a:xfrm>
+          <a:prstGeom prst="rect">
+            <a:avLst/>
+          </a:prstGeom>
+          <a:solidFill>
+            <a:srgbClr val="A020F0"/>
+          </a:solidFill>
+          <a:ln>
+            <a:noFill/>
+          </a:ln>
+          <a:effectLst/>
+        </p:spPr>
+        <p:style>
+          <a:lnRef idx="1">
+            <a:schemeClr val="accent1"/>
+          </a:lnRef>
+          <a:fillRef idx="3">
+            <a:schemeClr val="accent1"/>
+          </a:fillRef>
+          <a:effectRef idx="2">
+            <a:schemeClr val="accent1"/>
+          </a:effectRef>
+          <a:fontRef idx="minor">
+            <a:schemeClr val="lt1"/>
+          </a:fontRef>
+        </p:style>
+        <p:txBody>
+          <a:bodyPr rtlCol="0" anchor="ctr"/>
+          <a:lstStyle/>
+          <a:p>
+            <a:pPr algn="ctr"/>
+          </a:p>
+        </p:txBody>
+      </p:sp>
+      <p:pic>
+        <p:nvPicPr>
+          <p:cNvPr id="14" name="Picture 13" descr="kom_logo.png"/>
+          <p:cNvPicPr>
+            <a:picLocks noChangeAspect="1"/>
+          </p:cNvPicPr>
+          <p:nvPr/>
+        </p:nvPicPr>
+        <p:blipFill>
+          <a:blip r:embed="rId3"/>
+          <a:stretch>
+            <a:fillRect/>
+          </a:stretch>
+        </p:blipFill>
+        <p:spPr>
+          <a:xfrm>
+            <a:off x="10554730" y="6336792"/>
+            <a:ext cx="622780" cy="384048"/>
+          </a:xfrm>
+          <a:prstGeom prst="rect">
+            <a:avLst/>
+          </a:prstGeom>
+        </p:spPr>
+      </p:pic>
     </p:spTree>
   </p:cSld>
   <p:clrMapOvr>
@@ -4393,11 +5069,11 @@
             <a:r>
               <a:rPr lang="en-US" sz="2600" b="1" dirty="0">
                 <a:solidFill>
-                  <a:srgbClr val="15253D"/>
+                  <a:srgbClr val="2B1638"/>
                 </a:solidFill>
-                <a:latin typeface="Arial" pitchFamily="34" charset="0"/>
-                <a:ea typeface="Arial" pitchFamily="34" charset="-122"/>
-                <a:cs typeface="Arial" pitchFamily="34" charset="-120"/>
+                <a:latin typeface="Liberation Serif" pitchFamily="34" charset="0"/>
+                <a:ea typeface="Liberation Serif" pitchFamily="34" charset="-122"/>
+                <a:cs typeface="Liberation Serif" pitchFamily="34" charset="-120"/>
               </a:rPr>
               <a:t>Recommendations and key risks</a:t>
             </a:r>
@@ -4432,7 +5108,7 @@
             <a:r>
               <a:rPr lang="en-US" sz="1500" b="1" dirty="0">
                 <a:solidFill>
-                  <a:srgbClr val="0F766E"/>
+                  <a:srgbClr val="8E24D9"/>
                 </a:solidFill>
                 <a:latin typeface="Arial" pitchFamily="34" charset="0"/>
                 <a:ea typeface="Arial" pitchFamily="34" charset="-122"/>
@@ -4577,7 +5253,7 @@
             <a:r>
               <a:rPr lang="en-US" sz="1500" b="1" dirty="0">
                 <a:solidFill>
-                  <a:srgbClr val="EA580C"/>
+                  <a:srgbClr val="A020F0"/>
                 </a:solidFill>
                 <a:latin typeface="Arial" pitchFamily="34" charset="0"/>
                 <a:ea typeface="Arial" pitchFamily="34" charset="-122"/>
@@ -4604,11 +5280,11 @@
             <a:avLst/>
           </a:prstGeom>
           <a:solidFill>
-            <a:srgbClr val="F4F7FB"/>
+            <a:srgbClr val="FBF5FB"/>
           </a:solidFill>
           <a:ln w="12700">
             <a:solidFill>
-              <a:srgbClr val="F4F7FB"/>
+              <a:srgbClr val="FBF5FB"/>
             </a:solidFill>
             <a:prstDash val="solid"/>
           </a:ln>
@@ -4752,11 +5428,11 @@
             <a:avLst/>
           </a:prstGeom>
           <a:solidFill>
-            <a:srgbClr val="F4F7FB"/>
+            <a:srgbClr val="FBF5FB"/>
           </a:solidFill>
           <a:ln w="12700">
             <a:solidFill>
-              <a:srgbClr val="F4F7FB"/>
+              <a:srgbClr val="FBF5FB"/>
             </a:solidFill>
             <a:prstDash val="solid"/>
           </a:ln>
@@ -4900,11 +5576,11 @@
             <a:avLst/>
           </a:prstGeom>
           <a:solidFill>
-            <a:srgbClr val="F4F7FB"/>
+            <a:srgbClr val="FBF5FB"/>
           </a:solidFill>
           <a:ln w="12700">
             <a:solidFill>
-              <a:srgbClr val="F4F7FB"/>
+              <a:srgbClr val="FBF5FB"/>
             </a:solidFill>
             <a:prstDash val="solid"/>
           </a:ln>
@@ -5048,11 +5724,11 @@
             <a:avLst/>
           </a:prstGeom>
           <a:solidFill>
-            <a:srgbClr val="F4F7FB"/>
+            <a:srgbClr val="FBF5FB"/>
           </a:solidFill>
           <a:ln w="12700">
             <a:solidFill>
-              <a:srgbClr val="F4F7FB"/>
+              <a:srgbClr val="FBF5FB"/>
             </a:solidFill>
             <a:prstDash val="solid"/>
           </a:ln>
@@ -5259,6 +5935,118 @@
           </a:p>
         </p:txBody>
       </p:sp>
+      <p:sp>
+        <p:nvSpPr>
+          <p:cNvPr id="24" name="Rectangle 23"/>
+          <p:cNvSpPr/>
+          <p:nvPr/>
+        </p:nvSpPr>
+        <p:spPr>
+          <a:xfrm>
+            <a:off x="0" y="0"/>
+            <a:ext cx="12192000" cy="82296"/>
+          </a:xfrm>
+          <a:prstGeom prst="rect">
+            <a:avLst/>
+          </a:prstGeom>
+          <a:solidFill>
+            <a:srgbClr val="2B1638"/>
+          </a:solidFill>
+          <a:ln>
+            <a:noFill/>
+          </a:ln>
+          <a:effectLst/>
+        </p:spPr>
+        <p:style>
+          <a:lnRef idx="1">
+            <a:schemeClr val="accent1"/>
+          </a:lnRef>
+          <a:fillRef idx="3">
+            <a:schemeClr val="accent1"/>
+          </a:fillRef>
+          <a:effectRef idx="2">
+            <a:schemeClr val="accent1"/>
+          </a:effectRef>
+          <a:fontRef idx="minor">
+            <a:schemeClr val="lt1"/>
+          </a:fontRef>
+        </p:style>
+        <p:txBody>
+          <a:bodyPr rtlCol="0" anchor="ctr"/>
+          <a:lstStyle/>
+          <a:p>
+            <a:pPr algn="ctr"/>
+          </a:p>
+        </p:txBody>
+      </p:sp>
+      <p:sp>
+        <p:nvSpPr>
+          <p:cNvPr id="25" name="Rectangle 24"/>
+          <p:cNvSpPr/>
+          <p:nvPr/>
+        </p:nvSpPr>
+        <p:spPr>
+          <a:xfrm>
+            <a:off x="0" y="82296"/>
+            <a:ext cx="1463040" cy="45720"/>
+          </a:xfrm>
+          <a:prstGeom prst="rect">
+            <a:avLst/>
+          </a:prstGeom>
+          <a:solidFill>
+            <a:srgbClr val="A020F0"/>
+          </a:solidFill>
+          <a:ln>
+            <a:noFill/>
+          </a:ln>
+          <a:effectLst/>
+        </p:spPr>
+        <p:style>
+          <a:lnRef idx="1">
+            <a:schemeClr val="accent1"/>
+          </a:lnRef>
+          <a:fillRef idx="3">
+            <a:schemeClr val="accent1"/>
+          </a:fillRef>
+          <a:effectRef idx="2">
+            <a:schemeClr val="accent1"/>
+          </a:effectRef>
+          <a:fontRef idx="minor">
+            <a:schemeClr val="lt1"/>
+          </a:fontRef>
+        </p:style>
+        <p:txBody>
+          <a:bodyPr rtlCol="0" anchor="ctr"/>
+          <a:lstStyle/>
+          <a:p>
+            <a:pPr algn="ctr"/>
+          </a:p>
+        </p:txBody>
+      </p:sp>
+      <p:pic>
+        <p:nvPicPr>
+          <p:cNvPr id="26" name="Picture 25" descr="kom_logo.png"/>
+          <p:cNvPicPr>
+            <a:picLocks noChangeAspect="1"/>
+          </p:cNvPicPr>
+          <p:nvPr/>
+        </p:nvPicPr>
+        <p:blipFill>
+          <a:blip r:embed="rId3"/>
+          <a:stretch>
+            <a:fillRect/>
+          </a:stretch>
+        </p:blipFill>
+        <p:spPr>
+          <a:xfrm>
+            <a:off x="10554730" y="6336792"/>
+            <a:ext cx="622780" cy="384048"/>
+          </a:xfrm>
+          <a:prstGeom prst="rect">
+            <a:avLst/>
+          </a:prstGeom>
+        </p:spPr>
+      </p:pic>
     </p:spTree>
   </p:cSld>
   <p:clrMapOvr>

</xml_diff>